<commit_message>
Add the hand-label check to the scoring slide
Co-Authored-By: Claude Opus 5.5 (1M context) <noreply@anthropic.com>
Claude-Session: https://claude.ai/code/session_01TYh2oZekjeFqNyAvHawtCz
</commit_message>
<xml_diff>
--- a/deck/code_of_silence_deck.pptx
+++ b/deck/code_of_silence_deck.pptx
@@ -12715,7 +12715,25 @@
                 </a:solidFill>
                 <a:latin typeface="Segoe UI"/>
               </a:rPr>
-              <a:t>Gemma-3-12B relabels a stratified sample of 600 harm and 276 privacy posts and tips; Cohen's kappa 0.85 and 0.91.</a:t>
+              <a:t>Gemma-3-12B relabels a stratified sample of 600 harm and 276 privacy posts and tips; Cohen's kappa 0.85 and 0.91. </a:t>
+            </a:r>
+            <a:r>
+              <a:rPr sz="1300" b="1">
+                <a:solidFill>
+                  <a:srgbClr val="0F172A"/>
+                </a:solidFill>
+                <a:latin typeface="Segoe UI"/>
+              </a:rPr>
+              <a:t>Hand labels (60, blind): </a:t>
+            </a:r>
+            <a:r>
+              <a:rPr sz="1300" b="0">
+                <a:solidFill>
+                  <a:srgbClr val="475569"/>
+                </a:solidFill>
+                <a:latin typeface="Segoe UI"/>
+              </a:rPr>
+              <a:t>warns or stops sales, kappa 0.67; finer labels 0.33 to 0.42.</a:t>
             </a:r>
           </a:p>
         </p:txBody>

</xml_diff>